<commit_message>
updating week 4 documents, including data, for the 2026/2027 academic year
</commit_message>
<xml_diff>
--- a/PSYC7142/part1/ppt/wk4/PSYC7142 Lecture week4 part1 handout.pptx
+++ b/PSYC7142/part1/ppt/wk4/PSYC7142 Lecture week4 part1 handout.pptx
@@ -14,7 +14,7 @@
     <p:handoutMasterId r:id="rId17"/>
   </p:handoutMasterIdLst>
   <p:sldIdLst>
-    <p:sldId id="896" r:id="rId5"/>
+    <p:sldId id="452" r:id="rId5"/>
     <p:sldId id="901" r:id="rId6"/>
     <p:sldId id="420" r:id="rId7"/>
     <p:sldId id="884" r:id="rId8"/>
@@ -336,7 +336,7 @@
           <a:p>
             <a:fld id="{1ED63D20-B0B3-D445-877E-AF329FAFBC9C}" type="datetimeFigureOut">
               <a:rPr lang="en-US" smtClean="0"/>
-              <a:t>10/2/24</a:t>
+              <a:t>10/19/2026</a:t>
             </a:fld>
             <a:endParaRPr lang="en-GB"/>
           </a:p>
@@ -501,7 +501,7 @@
           <a:p>
             <a:fld id="{3D4CEEAF-8027-F64C-B8DD-D7E422C7FD2F}" type="datetimeFigureOut">
               <a:rPr lang="en-US" smtClean="0"/>
-              <a:t>10/2/24</a:t>
+              <a:t>10/19/2026</a:t>
             </a:fld>
             <a:endParaRPr lang="en-GB"/>
           </a:p>
@@ -818,7 +818,7 @@
           <a:p>
             <a:fld id="{8014A0CB-84B6-8842-8670-F7D58B08EA78}" type="datetimeFigureOut">
               <a:rPr lang="en-US" smtClean="0"/>
-              <a:t>10/2/24</a:t>
+              <a:t>10/19/2026</a:t>
             </a:fld>
             <a:endParaRPr lang="en-GB"/>
           </a:p>
@@ -1307,7 +1307,7 @@
             <a:fld id="{012ADEB9-B943-4968-ADF2-270CE1983704}" type="datetimeFigureOut">
               <a:rPr lang="en-GB" smtClean="0"/>
               <a:pPr/>
-              <a:t>02/10/2024</a:t>
+              <a:t>19/10/2026</a:t>
             </a:fld>
             <a:endParaRPr lang="en-GB"/>
           </a:p>
@@ -1674,7 +1674,7 @@
             <a:fld id="{012ADEB9-B943-4968-ADF2-270CE1983704}" type="datetimeFigureOut">
               <a:rPr lang="en-GB" smtClean="0"/>
               <a:pPr/>
-              <a:t>02/10/2024</a:t>
+              <a:t>19/10/2026</a:t>
             </a:fld>
             <a:endParaRPr lang="en-GB"/>
           </a:p>
@@ -2193,7 +2193,7 @@
             <a:fld id="{97CA41E8-ABA4-4C5B-81A5-5CD889FC8C0C}" type="datetimeFigureOut">
               <a:rPr lang="en-GB" smtClean="0"/>
               <a:pPr/>
-              <a:t>02/10/2024</a:t>
+              <a:t>19/10/2026</a:t>
             </a:fld>
             <a:endParaRPr lang="en-GB"/>
           </a:p>
@@ -2568,7 +2568,7 @@
             <a:fld id="{97CA41E8-ABA4-4C5B-81A5-5CD889FC8C0C}" type="datetimeFigureOut">
               <a:rPr lang="en-GB" smtClean="0"/>
               <a:pPr/>
-              <a:t>02/10/2024</a:t>
+              <a:t>19/10/2026</a:t>
             </a:fld>
             <a:endParaRPr lang="en-GB"/>
           </a:p>
@@ -2970,7 +2970,7 @@
             <a:fld id="{012ADEB9-B943-4968-ADF2-270CE1983704}" type="datetimeFigureOut">
               <a:rPr lang="en-GB" smtClean="0"/>
               <a:pPr/>
-              <a:t>02/10/2024</a:t>
+              <a:t>19/10/2026</a:t>
             </a:fld>
             <a:endParaRPr lang="en-GB"/>
           </a:p>
@@ -3300,7 +3300,7 @@
             <a:fld id="{012ADEB9-B943-4968-ADF2-270CE1983704}" type="datetimeFigureOut">
               <a:rPr lang="en-GB" smtClean="0"/>
               <a:pPr/>
-              <a:t>02/10/2024</a:t>
+              <a:t>19/10/2026</a:t>
             </a:fld>
             <a:endParaRPr lang="en-GB"/>
           </a:p>
@@ -3559,7 +3559,7 @@
             <a:fld id="{012ADEB9-B943-4968-ADF2-270CE1983704}" type="datetimeFigureOut">
               <a:rPr lang="en-GB" smtClean="0"/>
               <a:pPr/>
-              <a:t>02/10/2024</a:t>
+              <a:t>19/10/2026</a:t>
             </a:fld>
             <a:endParaRPr lang="en-GB"/>
           </a:p>
@@ -3703,7 +3703,7 @@
           <a:p>
             <a:fld id="{8014A0CB-84B6-8842-8670-F7D58B08EA78}" type="datetimeFigureOut">
               <a:rPr lang="en-US" smtClean="0"/>
-              <a:t>10/2/24</a:t>
+              <a:t>10/19/2026</a:t>
             </a:fld>
             <a:endParaRPr lang="en-GB"/>
           </a:p>
@@ -5595,7 +5595,7 @@
             <a:fld id="{012ADEB9-B943-4968-ADF2-270CE1983704}" type="datetimeFigureOut">
               <a:rPr lang="en-GB" smtClean="0"/>
               <a:pPr/>
-              <a:t>02/10/2024</a:t>
+              <a:t>19/10/2026</a:t>
             </a:fld>
             <a:endParaRPr lang="en-GB" dirty="0"/>
           </a:p>
@@ -5722,314 +5722,6 @@
     <p:extLst>
       <p:ext uri="{BB962C8B-B14F-4D97-AF65-F5344CB8AC3E}">
         <p14:creationId xmlns:p14="http://schemas.microsoft.com/office/powerpoint/2010/main" val="4210385221"/>
-      </p:ext>
-    </p:extLst>
-  </p:cSld>
-  <p:clrMapOvr>
-    <a:masterClrMapping/>
-  </p:clrMapOvr>
-</p:sldLayout>
-</file>
-
-<file path=ppt/slideLayouts/slideLayout28.xml><?xml version="1.0" encoding="utf-8"?>
-<p:sldLayout xmlns:a="http://schemas.openxmlformats.org/drawingml/2006/main" xmlns:r="http://schemas.openxmlformats.org/officeDocument/2006/relationships" xmlns:p="http://schemas.openxmlformats.org/presentationml/2006/main">
-  <p:cSld name="Title Slide">
-    <p:spTree>
-      <p:nvGrpSpPr>
-        <p:cNvPr id="1" name=""/>
-        <p:cNvGrpSpPr/>
-        <p:nvPr/>
-      </p:nvGrpSpPr>
-      <p:grpSpPr>
-        <a:xfrm>
-          <a:off x="0" y="0"/>
-          <a:ext cx="0" cy="0"/>
-          <a:chOff x="0" y="0"/>
-          <a:chExt cx="0" cy="0"/>
-        </a:xfrm>
-      </p:grpSpPr>
-      <p:sp>
-        <p:nvSpPr>
-          <p:cNvPr id="4" name="Date Placeholder 3"/>
-          <p:cNvSpPr>
-            <a:spLocks noGrp="1"/>
-          </p:cNvSpPr>
-          <p:nvPr>
-            <p:ph type="dt" sz="half" idx="10"/>
-          </p:nvPr>
-        </p:nvSpPr>
-        <p:spPr>
-          <a:xfrm>
-            <a:off x="457200" y="6356350"/>
-            <a:ext cx="2133600" cy="365125"/>
-          </a:xfrm>
-          <a:prstGeom prst="rect">
-            <a:avLst/>
-          </a:prstGeom>
-        </p:spPr>
-        <p:txBody>
-          <a:bodyPr/>
-          <a:lstStyle>
-            <a:lvl1pPr>
-              <a:defRPr>
-                <a:solidFill>
-                  <a:srgbClr val="666666"/>
-                </a:solidFill>
-              </a:defRPr>
-            </a:lvl1pPr>
-          </a:lstStyle>
-          <a:p>
-            <a:fld id="{8014A0CB-84B6-8842-8670-F7D58B08EA78}" type="datetimeFigureOut">
-              <a:rPr lang="en-US" smtClean="0"/>
-              <a:t>10/2/24</a:t>
-            </a:fld>
-            <a:endParaRPr lang="en-GB"/>
-          </a:p>
-        </p:txBody>
-      </p:sp>
-      <p:sp>
-        <p:nvSpPr>
-          <p:cNvPr id="5" name="Footer Placeholder 4"/>
-          <p:cNvSpPr>
-            <a:spLocks noGrp="1"/>
-          </p:cNvSpPr>
-          <p:nvPr>
-            <p:ph type="ftr" sz="quarter" idx="11"/>
-          </p:nvPr>
-        </p:nvSpPr>
-        <p:spPr>
-          <a:xfrm>
-            <a:off x="3124200" y="6356350"/>
-            <a:ext cx="2895600" cy="365125"/>
-          </a:xfrm>
-          <a:prstGeom prst="rect">
-            <a:avLst/>
-          </a:prstGeom>
-        </p:spPr>
-        <p:txBody>
-          <a:bodyPr/>
-          <a:lstStyle>
-            <a:lvl1pPr>
-              <a:defRPr>
-                <a:solidFill>
-                  <a:srgbClr val="666666"/>
-                </a:solidFill>
-              </a:defRPr>
-            </a:lvl1pPr>
-          </a:lstStyle>
-          <a:p>
-            <a:endParaRPr lang="en-GB"/>
-          </a:p>
-        </p:txBody>
-      </p:sp>
-      <p:sp>
-        <p:nvSpPr>
-          <p:cNvPr id="6" name="Slide Number Placeholder 5"/>
-          <p:cNvSpPr>
-            <a:spLocks noGrp="1"/>
-          </p:cNvSpPr>
-          <p:nvPr>
-            <p:ph type="sldNum" sz="quarter" idx="12"/>
-          </p:nvPr>
-        </p:nvSpPr>
-        <p:spPr>
-          <a:xfrm>
-            <a:off x="6553200" y="6356350"/>
-            <a:ext cx="2133600" cy="365125"/>
-          </a:xfrm>
-          <a:prstGeom prst="rect">
-            <a:avLst/>
-          </a:prstGeom>
-        </p:spPr>
-        <p:txBody>
-          <a:bodyPr/>
-          <a:lstStyle>
-            <a:lvl1pPr>
-              <a:defRPr>
-                <a:solidFill>
-                  <a:srgbClr val="666666"/>
-                </a:solidFill>
-              </a:defRPr>
-            </a:lvl1pPr>
-          </a:lstStyle>
-          <a:p>
-            <a:fld id="{5E97FB9A-8473-8B4D-B336-D320A6A1F7C6}" type="slidenum">
-              <a:rPr lang="en-GB" smtClean="0"/>
-              <a:t>‹#›</a:t>
-            </a:fld>
-            <a:endParaRPr lang="en-GB"/>
-          </a:p>
-        </p:txBody>
-      </p:sp>
-      <p:sp>
-        <p:nvSpPr>
-          <p:cNvPr id="9" name="Title 1"/>
-          <p:cNvSpPr>
-            <a:spLocks noGrp="1"/>
-          </p:cNvSpPr>
-          <p:nvPr>
-            <p:ph type="ctrTitle"/>
-          </p:nvPr>
-        </p:nvSpPr>
-        <p:spPr>
-          <a:xfrm>
-            <a:off x="467544" y="1556792"/>
-            <a:ext cx="8208912" cy="1010543"/>
-          </a:xfrm>
-          <a:prstGeom prst="rect">
-            <a:avLst/>
-          </a:prstGeom>
-        </p:spPr>
-        <p:txBody>
-          <a:bodyPr/>
-          <a:lstStyle>
-            <a:lvl1pPr algn="l">
-              <a:lnSpc>
-                <a:spcPts val="3500"/>
-              </a:lnSpc>
-              <a:defRPr sz="3600">
-                <a:solidFill>
-                  <a:srgbClr val="D52B1E"/>
-                </a:solidFill>
-              </a:defRPr>
-            </a:lvl1pPr>
-          </a:lstStyle>
-          <a:p>
-            <a:r>
-              <a:rPr lang="en-GB"/>
-              <a:t>Click to edit Master title style</a:t>
-            </a:r>
-            <a:endParaRPr lang="en-GB" dirty="0"/>
-          </a:p>
-        </p:txBody>
-      </p:sp>
-      <p:sp>
-        <p:nvSpPr>
-          <p:cNvPr id="10" name="Subtitle 2"/>
-          <p:cNvSpPr>
-            <a:spLocks noGrp="1"/>
-          </p:cNvSpPr>
-          <p:nvPr>
-            <p:ph type="subTitle" idx="1"/>
-          </p:nvPr>
-        </p:nvSpPr>
-        <p:spPr>
-          <a:xfrm>
-            <a:off x="467544" y="2852936"/>
-            <a:ext cx="8208912" cy="720080"/>
-          </a:xfrm>
-          <a:prstGeom prst="rect">
-            <a:avLst/>
-          </a:prstGeom>
-        </p:spPr>
-        <p:txBody>
-          <a:bodyPr/>
-          <a:lstStyle>
-            <a:lvl1pPr marL="0" indent="0" algn="l">
-              <a:spcBef>
-                <a:spcPts val="0"/>
-              </a:spcBef>
-              <a:buNone/>
-              <a:defRPr sz="1600">
-                <a:solidFill>
-                  <a:srgbClr val="666666"/>
-                </a:solidFill>
-              </a:defRPr>
-            </a:lvl1pPr>
-            <a:lvl2pPr marL="457200" indent="0" algn="ctr">
-              <a:buNone/>
-              <a:defRPr>
-                <a:solidFill>
-                  <a:schemeClr val="tx1">
-                    <a:tint val="75000"/>
-                  </a:schemeClr>
-                </a:solidFill>
-              </a:defRPr>
-            </a:lvl2pPr>
-            <a:lvl3pPr marL="914400" indent="0" algn="ctr">
-              <a:buNone/>
-              <a:defRPr>
-                <a:solidFill>
-                  <a:schemeClr val="tx1">
-                    <a:tint val="75000"/>
-                  </a:schemeClr>
-                </a:solidFill>
-              </a:defRPr>
-            </a:lvl3pPr>
-            <a:lvl4pPr marL="1371600" indent="0" algn="ctr">
-              <a:buNone/>
-              <a:defRPr>
-                <a:solidFill>
-                  <a:schemeClr val="tx1">
-                    <a:tint val="75000"/>
-                  </a:schemeClr>
-                </a:solidFill>
-              </a:defRPr>
-            </a:lvl4pPr>
-            <a:lvl5pPr marL="1828800" indent="0" algn="ctr">
-              <a:buNone/>
-              <a:defRPr>
-                <a:solidFill>
-                  <a:schemeClr val="tx1">
-                    <a:tint val="75000"/>
-                  </a:schemeClr>
-                </a:solidFill>
-              </a:defRPr>
-            </a:lvl5pPr>
-            <a:lvl6pPr marL="2286000" indent="0" algn="ctr">
-              <a:buNone/>
-              <a:defRPr>
-                <a:solidFill>
-                  <a:schemeClr val="tx1">
-                    <a:tint val="75000"/>
-                  </a:schemeClr>
-                </a:solidFill>
-              </a:defRPr>
-            </a:lvl6pPr>
-            <a:lvl7pPr marL="2743200" indent="0" algn="ctr">
-              <a:buNone/>
-              <a:defRPr>
-                <a:solidFill>
-                  <a:schemeClr val="tx1">
-                    <a:tint val="75000"/>
-                  </a:schemeClr>
-                </a:solidFill>
-              </a:defRPr>
-            </a:lvl7pPr>
-            <a:lvl8pPr marL="3200400" indent="0" algn="ctr">
-              <a:buNone/>
-              <a:defRPr>
-                <a:solidFill>
-                  <a:schemeClr val="tx1">
-                    <a:tint val="75000"/>
-                  </a:schemeClr>
-                </a:solidFill>
-              </a:defRPr>
-            </a:lvl8pPr>
-            <a:lvl9pPr marL="3657600" indent="0" algn="ctr">
-              <a:buNone/>
-              <a:defRPr>
-                <a:solidFill>
-                  <a:schemeClr val="tx1">
-                    <a:tint val="75000"/>
-                  </a:schemeClr>
-                </a:solidFill>
-              </a:defRPr>
-            </a:lvl9pPr>
-          </a:lstStyle>
-          <a:p>
-            <a:r>
-              <a:rPr lang="en-GB"/>
-              <a:t>Click to edit Master subtitle style</a:t>
-            </a:r>
-            <a:endParaRPr lang="en-GB" dirty="0"/>
-          </a:p>
-        </p:txBody>
-      </p:sp>
-    </p:spTree>
-    <p:extLst>
-      <p:ext uri="{BB962C8B-B14F-4D97-AF65-F5344CB8AC3E}">
-        <p14:creationId xmlns:p14="http://schemas.microsoft.com/office/powerpoint/2010/main" val="1124397403"/>
       </p:ext>
     </p:extLst>
   </p:cSld>
@@ -6186,7 +5878,7 @@
             <a:fld id="{012ADEB9-B943-4968-ADF2-270CE1983704}" type="datetimeFigureOut">
               <a:rPr lang="en-GB" smtClean="0"/>
               <a:pPr/>
-              <a:t>02/10/2024</a:t>
+              <a:t>19/10/2026</a:t>
             </a:fld>
             <a:endParaRPr lang="en-GB" dirty="0"/>
           </a:p>
@@ -6469,7 +6161,7 @@
             <a:fld id="{012ADEB9-B943-4968-ADF2-270CE1983704}" type="datetimeFigureOut">
               <a:rPr lang="en-GB" smtClean="0"/>
               <a:pPr/>
-              <a:t>02/10/2024</a:t>
+              <a:t>19/10/2026</a:t>
             </a:fld>
             <a:endParaRPr lang="en-GB" dirty="0"/>
           </a:p>
@@ -6752,7 +6444,7 @@
             <a:fld id="{012ADEB9-B943-4968-ADF2-270CE1983704}" type="datetimeFigureOut">
               <a:rPr lang="en-GB" smtClean="0"/>
               <a:pPr/>
-              <a:t>02/10/2024</a:t>
+              <a:t>19/10/2026</a:t>
             </a:fld>
             <a:endParaRPr lang="en-GB" dirty="0"/>
           </a:p>
@@ -7119,7 +6811,7 @@
             <a:fld id="{97CA41E8-ABA4-4C5B-81A5-5CD889FC8C0C}" type="datetimeFigureOut">
               <a:rPr lang="en-GB" smtClean="0"/>
               <a:pPr/>
-              <a:t>02/10/2024</a:t>
+              <a:t>19/10/2026</a:t>
             </a:fld>
             <a:endParaRPr lang="en-GB"/>
           </a:p>
@@ -7773,7 +7465,7 @@
             <a:fld id="{97CA41E8-ABA4-4C5B-81A5-5CD889FC8C0C}" type="datetimeFigureOut">
               <a:rPr lang="en-GB" smtClean="0"/>
               <a:pPr/>
-              <a:t>02/10/2024</a:t>
+              <a:t>19/10/2026</a:t>
             </a:fld>
             <a:endParaRPr lang="en-GB"/>
           </a:p>
@@ -7960,7 +7652,7 @@
             <a:fld id="{012ADEB9-B943-4968-ADF2-270CE1983704}" type="datetimeFigureOut">
               <a:rPr lang="en-GB" smtClean="0"/>
               <a:pPr/>
-              <a:t>02/10/2024</a:t>
+              <a:t>19/10/2026</a:t>
             </a:fld>
             <a:endParaRPr lang="en-GB"/>
           </a:p>
@@ -8147,7 +7839,7 @@
             <a:fld id="{012ADEB9-B943-4968-ADF2-270CE1983704}" type="datetimeFigureOut">
               <a:rPr lang="en-GB" smtClean="0"/>
               <a:pPr/>
-              <a:t>02/10/2024</a:t>
+              <a:t>19/10/2026</a:t>
             </a:fld>
             <a:endParaRPr lang="en-GB"/>
           </a:p>
@@ -9342,7 +9034,7 @@
           <p:nvPr/>
         </p:nvPicPr>
         <p:blipFill>
-          <a:blip r:embed="rId11" cstate="print">
+          <a:blip r:embed="rId10" cstate="print">
             <a:extLst>
               <a:ext uri="{28A0092B-C50C-407E-A947-70E740481C1C}">
                 <a14:useLocalDpi xmlns:a14="http://schemas.microsoft.com/office/drawing/2010/main" val="0"/>
@@ -9382,7 +9074,6 @@
     <p:sldLayoutId id="2147483689" r:id="rId6"/>
     <p:sldLayoutId id="2147483690" r:id="rId7"/>
     <p:sldLayoutId id="2147483691" r:id="rId8"/>
-    <p:sldLayoutId id="2147483692" r:id="rId9"/>
   </p:sldLayoutIdLst>
   <p:txStyles>
     <p:titleStyle>
@@ -9656,182 +9347,124 @@
       </p:grpSpPr>
       <p:sp>
         <p:nvSpPr>
-          <p:cNvPr id="23554" name="Title 1"/>
-          <p:cNvSpPr>
-            <a:spLocks noGrp="1"/>
-          </p:cNvSpPr>
-          <p:nvPr>
-            <p:ph type="ctrTitle"/>
-          </p:nvPr>
-        </p:nvSpPr>
-        <p:spPr bwMode="auto">
-          <a:noFill/>
-          <a:ln>
-            <a:miter lim="800000"/>
-            <a:headEnd/>
-            <a:tailEnd/>
-          </a:ln>
-        </p:spPr>
-        <p:txBody>
-          <a:bodyPr vert="horz" wrap="square" lIns="91440" tIns="45720" rIns="91440" bIns="45720" numCol="1" anchor="t" anchorCtr="0" compatLnSpc="1">
-            <a:prstTxWarp prst="textNoShape">
-              <a:avLst/>
-            </a:prstTxWarp>
-            <a:normAutofit/>
-          </a:bodyPr>
-          <a:lstStyle/>
-          <a:p>
-            <a:pPr eaLnBrk="1" hangingPunct="1"/>
-            <a:r>
-              <a:rPr lang="en-GB" dirty="0">
-                <a:solidFill>
-                  <a:srgbClr val="A70000"/>
-                </a:solidFill>
-              </a:rPr>
-              <a:t>PSYC401: Analysing and Interpreting Psychological Data I</a:t>
-            </a:r>
-          </a:p>
-        </p:txBody>
-      </p:sp>
-      <p:sp>
-        <p:nvSpPr>
-          <p:cNvPr id="23555" name="Subtitle 2"/>
-          <p:cNvSpPr>
-            <a:spLocks noGrp="1"/>
-          </p:cNvSpPr>
-          <p:nvPr>
-            <p:ph type="subTitle" idx="1"/>
-          </p:nvPr>
-        </p:nvSpPr>
-        <p:spPr bwMode="auto">
-          <a:noFill/>
-          <a:ln>
-            <a:miter lim="800000"/>
-            <a:headEnd/>
-            <a:tailEnd/>
-          </a:ln>
-        </p:spPr>
-        <p:txBody>
-          <a:bodyPr vert="horz" wrap="square" lIns="91440" tIns="45720" rIns="91440" bIns="45720" numCol="1" anchor="t" anchorCtr="0" compatLnSpc="1">
-            <a:prstTxWarp prst="textNoShape">
-              <a:avLst/>
-            </a:prstTxWarp>
-            <a:normAutofit fontScale="92500" lnSpcReduction="10000"/>
-          </a:bodyPr>
-          <a:lstStyle/>
-          <a:p>
-            <a:pPr eaLnBrk="1" hangingPunct="1">
-              <a:spcBef>
-                <a:spcPct val="0"/>
-              </a:spcBef>
-            </a:pPr>
-            <a:r>
-              <a:rPr lang="en-GB" dirty="0"/>
-              <a:t>Padraic Monaghan</a:t>
-            </a:r>
-          </a:p>
-          <a:p>
-            <a:pPr eaLnBrk="1" hangingPunct="1">
-              <a:spcBef>
-                <a:spcPct val="0"/>
-              </a:spcBef>
-            </a:pPr>
-            <a:r>
-              <a:rPr lang="en-GB" dirty="0"/>
-              <a:t>Room C5, Fylde College</a:t>
-            </a:r>
-          </a:p>
-          <a:p>
-            <a:pPr eaLnBrk="1" hangingPunct="1">
-              <a:spcBef>
-                <a:spcPct val="0"/>
-              </a:spcBef>
-            </a:pPr>
-            <a:r>
-              <a:rPr lang="en-GB" dirty="0" err="1"/>
-              <a:t>p.monaghan@lancaster.ac.uk</a:t>
-            </a:r>
-            <a:endParaRPr lang="en-GB" dirty="0"/>
-          </a:p>
-        </p:txBody>
-      </p:sp>
-      <p:sp>
-        <p:nvSpPr>
-          <p:cNvPr id="5" name="Rectangle 4" title="black rectangle background"/>
-          <p:cNvSpPr/>
-          <p:nvPr/>
-        </p:nvSpPr>
-        <p:spPr>
-          <a:xfrm>
-            <a:off x="0" y="-269"/>
-            <a:ext cx="9144000" cy="6858269"/>
-          </a:xfrm>
-          <a:prstGeom prst="rect">
-            <a:avLst/>
-          </a:prstGeom>
-          <a:solidFill>
-            <a:srgbClr val="000000"/>
-          </a:solidFill>
-        </p:spPr>
-        <p:style>
-          <a:lnRef idx="2">
-            <a:schemeClr val="accent1">
-              <a:shade val="50000"/>
-            </a:schemeClr>
-          </a:lnRef>
-          <a:fillRef idx="1">
-            <a:schemeClr val="accent1"/>
-          </a:fillRef>
-          <a:effectRef idx="0">
-            <a:schemeClr val="accent1"/>
-          </a:effectRef>
-          <a:fontRef idx="minor">
-            <a:schemeClr val="lt1"/>
-          </a:fontRef>
-        </p:style>
-        <p:txBody>
-          <a:bodyPr rtlCol="0" anchor="ctr"/>
-          <a:lstStyle/>
-          <a:p>
-            <a:pPr algn="ctr"/>
-            <a:endParaRPr lang="en-US"/>
-          </a:p>
-        </p:txBody>
-      </p:sp>
-      <p:pic>
-        <p:nvPicPr>
-          <p:cNvPr id="7" name="Picture 6" descr="A cover of a video game&#10;&#10;Description automatically generated">
+          <p:cNvPr id="2" name="Title 1">
             <a:extLst>
               <a:ext uri="{FF2B5EF4-FFF2-40B4-BE49-F238E27FC236}">
-                <a16:creationId xmlns:a16="http://schemas.microsoft.com/office/drawing/2014/main" id="{127B235A-B636-D291-18D2-14CE8A4D3862}"/>
+                <a16:creationId xmlns:a16="http://schemas.microsoft.com/office/drawing/2014/main" id="{82E5AFB5-F21B-B858-0014-321A6B158879}"/>
               </a:ext>
             </a:extLst>
           </p:cNvPr>
-          <p:cNvPicPr>
-            <a:picLocks noChangeAspect="1"/>
-          </p:cNvPicPr>
+          <p:cNvSpPr>
+            <a:spLocks noGrp="1"/>
+          </p:cNvSpPr>
+          <p:nvPr>
+            <p:ph type="ctrTitle"/>
+          </p:nvPr>
+        </p:nvSpPr>
+        <p:spPr>
+          <a:xfrm>
+            <a:off x="189690" y="176720"/>
+            <a:ext cx="6788619" cy="1152128"/>
+          </a:xfrm>
+        </p:spPr>
+        <p:txBody>
+          <a:bodyPr/>
+          <a:lstStyle/>
+          <a:p>
+            <a:r>
+              <a:rPr lang="en-GB" dirty="0"/>
+              <a:t>PSY7142 Understanding Humans Through Data</a:t>
+            </a:r>
+          </a:p>
+        </p:txBody>
+      </p:sp>
+      <p:grpSp>
+        <p:nvGrpSpPr>
+          <p:cNvPr id="7" name="Group 6">
+            <a:extLst>
+              <a:ext uri="{FF2B5EF4-FFF2-40B4-BE49-F238E27FC236}">
+                <a16:creationId xmlns:a16="http://schemas.microsoft.com/office/drawing/2014/main" id="{F6986505-B9A2-78D2-7E15-977F5B2D7BED}"/>
+              </a:ext>
+            </a:extLst>
+          </p:cNvPr>
+          <p:cNvGrpSpPr/>
           <p:nvPr/>
-        </p:nvPicPr>
-        <p:blipFill>
-          <a:blip r:embed="rId2"/>
-          <a:stretch>
-            <a:fillRect/>
-          </a:stretch>
-        </p:blipFill>
-        <p:spPr>
-          <a:xfrm>
-            <a:off x="2347310" y="0"/>
-            <a:ext cx="4449379" cy="6858000"/>
-          </a:xfrm>
-          <a:prstGeom prst="rect">
-            <a:avLst/>
-          </a:prstGeom>
-        </p:spPr>
-      </p:pic>
+        </p:nvGrpSpPr>
+        <p:grpSpPr>
+          <a:xfrm>
+            <a:off x="189690" y="1328848"/>
+            <a:ext cx="8744753" cy="4676745"/>
+            <a:chOff x="69742" y="2103132"/>
+            <a:chExt cx="9074258" cy="4378272"/>
+          </a:xfrm>
+        </p:grpSpPr>
+        <p:pic>
+          <p:nvPicPr>
+            <p:cNvPr id="4" name="Picture 3">
+              <a:extLst>
+                <a:ext uri="{FF2B5EF4-FFF2-40B4-BE49-F238E27FC236}">
+                  <a16:creationId xmlns:a16="http://schemas.microsoft.com/office/drawing/2014/main" id="{49F46379-5E74-7414-F5A5-7CEBFAD951A0}"/>
+                </a:ext>
+              </a:extLst>
+            </p:cNvPr>
+            <p:cNvPicPr>
+              <a:picLocks noChangeAspect="1"/>
+            </p:cNvPicPr>
+            <p:nvPr/>
+          </p:nvPicPr>
+          <p:blipFill>
+            <a:blip r:embed="rId2"/>
+            <a:srcRect r="20357"/>
+            <a:stretch>
+              <a:fillRect/>
+            </a:stretch>
+          </p:blipFill>
+          <p:spPr>
+            <a:xfrm>
+              <a:off x="69742" y="2103132"/>
+              <a:ext cx="5222929" cy="4378271"/>
+            </a:xfrm>
+            <a:prstGeom prst="rect">
+              <a:avLst/>
+            </a:prstGeom>
+          </p:spPr>
+        </p:pic>
+        <p:pic>
+          <p:nvPicPr>
+            <p:cNvPr id="6" name="Picture 5">
+              <a:extLst>
+                <a:ext uri="{FF2B5EF4-FFF2-40B4-BE49-F238E27FC236}">
+                  <a16:creationId xmlns:a16="http://schemas.microsoft.com/office/drawing/2014/main" id="{7578FD14-1F91-3F8C-26D4-E80A0B93213C}"/>
+                </a:ext>
+              </a:extLst>
+            </p:cNvPr>
+            <p:cNvPicPr>
+              <a:picLocks noChangeAspect="1"/>
+            </p:cNvPicPr>
+            <p:nvPr/>
+          </p:nvPicPr>
+          <p:blipFill>
+            <a:blip r:embed="rId3"/>
+            <a:srcRect t="19435" b="16723"/>
+            <a:stretch>
+              <a:fillRect/>
+            </a:stretch>
+          </p:blipFill>
+          <p:spPr>
+            <a:xfrm>
+              <a:off x="5286375" y="2103133"/>
+              <a:ext cx="3857625" cy="4378271"/>
+            </a:xfrm>
+            <a:prstGeom prst="rect">
+              <a:avLst/>
+            </a:prstGeom>
+          </p:spPr>
+        </p:pic>
+      </p:grpSp>
     </p:spTree>
     <p:extLst>
       <p:ext uri="{BB962C8B-B14F-4D97-AF65-F5344CB8AC3E}">
-        <p14:creationId xmlns:p14="http://schemas.microsoft.com/office/powerpoint/2010/main" val="2168155039"/>
+        <p14:creationId xmlns:p14="http://schemas.microsoft.com/office/powerpoint/2010/main" val="4174813708"/>
       </p:ext>
     </p:extLst>
   </p:cSld>

</xml_diff>